<commit_message>
Penutup: hapus ucapan kepada Komisi XIII DPR RI
Paparan disampaikan lebih dahulu kepada Direktorat Jenderal AHU,
sehingga kalimat "Atas perhatian Pimpinan dan Anggota Komisi XIII DPR
RI" dihapus dari slide penutup, catatan pembicara, dan cadangan
PowerPoint.

Co-Authored-By: Claude Opus 5.5 <noreply@anthropic.com>
Claude-Session: https://claude.ai/code/session_014sYGevs3jRGMQNTNQwr54Z
</commit_message>
<xml_diff>
--- a/presentasi/Paparan_BHP_Medan_RUU_Profesi_Kurator.pptx
+++ b/presentasi/Paparan_BHP_Medan_RUU_Profesi_Kurator.pptx
@@ -549,7 +549,7 @@
           <a:p>
             <a:r>
               <a:rPr lang="en-US" dirty="0"/>
-              <a:t>Pembukaan. Salam hormat kepada Pimpinan dan Anggota Komisi XIII DPR RI.</a:t>
+              <a:t>Pembukaan dan salam hormat.</a:t>
             </a:r>
             <a:endParaRPr lang="en-US" dirty="0"/>
           </a:p>
@@ -32366,45 +32366,6 @@
         </p:nvSpPr>
         <p:spPr>
           <a:xfrm>
-            <a:off x="731520" y="3200400"/>
-            <a:ext cx="10698480" cy="1097280"/>
-          </a:xfrm>
-          <a:prstGeom prst="rect">
-            <a:avLst/>
-          </a:prstGeom>
-          <a:noFill/>
-          <a:ln/>
-        </p:spPr>
-        <p:txBody>
-          <a:bodyPr wrap="square" lIns="0" tIns="0" rIns="0" bIns="0" rtlCol="0" anchor="t"/>
-          <a:lstStyle/>
-          <a:p>
-            <a:pPr indent="0" marL="0">
-              <a:buNone/>
-            </a:pPr>
-            <a:r>
-              <a:rPr lang="en-US" sz="2400" dirty="0">
-                <a:solidFill>
-                  <a:srgbClr val="FFFFFF"/>
-                </a:solidFill>
-                <a:latin typeface="Arial" pitchFamily="34" charset="0"/>
-                <a:ea typeface="Arial" pitchFamily="34" charset="-122"/>
-                <a:cs typeface="Arial" pitchFamily="34" charset="-120"/>
-              </a:rPr>
-              <a:t>Demikian bahan masukan ini disampaikan. Atas perhatian Pimpinan dan Anggota Komisi XIII DPR RI, kami ucapkan terima kasih.</a:t>
-            </a:r>
-            <a:endParaRPr lang="en-US" sz="2400" dirty="0"/>
-          </a:p>
-        </p:txBody>
-      </p:sp>
-      <p:sp>
-        <p:nvSpPr>
-          <p:cNvPr id="5" name="Text 3"/>
-          <p:cNvSpPr txBox="1"/>
-          <p:nvPr/>
-        </p:nvSpPr>
-        <p:spPr>
-          <a:xfrm>
             <a:off x="731520" y="4937760"/>
             <a:ext cx="10698480" cy="822960"/>
           </a:xfrm>

</xml_diff>

<commit_message>
Bersihkan em dash dan en dash dari seluruh berkas kerja
Bulet bawaan master slide (en dash) diganti bulet biasa pada kedua
PowerPoint; literal dash di skrip pendeteksi ditulis sebagai kode unicode.
Teks yang terbaca orang sudah bebas dash sejak awal.

Co-Authored-By: Claude Fable 5.1 <noreply@anthropic.com>
Claude-Session: https://claude.ai/code/session_01YRzsgeieNDAiMxdefdbbP3
</commit_message>
<xml_diff>
--- a/presentasi/Paparan_BHP_Medan_RUU_Profesi_Kurator.pptx
+++ b/presentasi/Paparan_BHP_Medan_RUU_Profesi_Kurator.pptx
@@ -3039,7 +3039,7 @@
           <a:spcPct val="20000"/>
         </a:spcBef>
         <a:buFont typeface="Arial" pitchFamily="34" charset="0"/>
-        <a:buChar char="–"/>
+        <a:buChar char="•"/>
         <a:defRPr sz="2800" kern="1200">
           <a:solidFill>
             <a:schemeClr val="tx1"/>
@@ -3069,7 +3069,7 @@
           <a:spcPct val="20000"/>
         </a:spcBef>
         <a:buFont typeface="Arial" pitchFamily="34" charset="0"/>
-        <a:buChar char="–"/>
+        <a:buChar char="•"/>
         <a:defRPr sz="2000" kern="1200">
           <a:solidFill>
             <a:schemeClr val="tx1"/>

</xml_diff>